<commit_message>
Typo in data attribute comix and bookmark
</commit_message>
<xml_diff>
--- a/Community_Contributions/Comixplain - Attribute Types Bookmark.pptx
+++ b/Community_Contributions/Comixplain - Attribute Types Bookmark.pptx
@@ -2,10 +2,10 @@
 <file path=ppt/presentation.xml><?xml version="1.0" encoding="utf-8"?>
 <p:presentation xmlns:a="http://schemas.openxmlformats.org/drawingml/2006/main" xmlns:r="http://schemas.openxmlformats.org/officeDocument/2006/relationships" xmlns:p="http://schemas.openxmlformats.org/presentationml/2006/main" saveSubsetFonts="1">
   <p:sldMasterIdLst>
-    <p:sldMasterId id="2147483660" r:id="rId1"/>
+    <p:sldMasterId id="2147483660" r:id="rId4"/>
   </p:sldMasterIdLst>
   <p:sldIdLst>
-    <p:sldId id="256" r:id="rId2"/>
+    <p:sldId id="256" r:id="rId5"/>
   </p:sldIdLst>
   <p:sldSz cx="13716000" cy="3382963"/>
   <p:notesSz cx="6858000" cy="9144000"/>
@@ -104,40 +104,101 @@
       </a:defRPr>
     </a:lvl9pPr>
   </p:defaultTextStyle>
+  <p:extLst>
+    <p:ext uri="{EFAFB233-063F-42B5-8137-9DF3F51BA10A}">
+      <p15:sldGuideLst xmlns:p15="http://schemas.microsoft.com/office/powerpoint/2012/main"/>
+    </p:ext>
+  </p:extLst>
 </p:presentation>
+</file>
+
+<file path=ppt/revisionInfo.xml><?xml version="1.0" encoding="utf-8"?>
+<p1510:revInfo xmlns:a="http://schemas.openxmlformats.org/drawingml/2006/main" xmlns:r="http://schemas.openxmlformats.org/officeDocument/2006/relationships" xmlns:p1510="http://schemas.microsoft.com/office/powerpoint/2015/10/main">
+  <p1510:revLst>
+    <p1510:client id="{1BEE2CFF-B1B0-40E8-A791-D4A36802560F}" v="2" dt="2026-08-05T10:04:28.790"/>
+  </p1510:revLst>
+</p1510:revInfo>
 </file>
 
 <file path=ppt/changesInfos/changesInfo1.xml><?xml version="1.0" encoding="utf-8"?>
 <pc:chgInfo xmlns:a="http://schemas.openxmlformats.org/drawingml/2006/main" xmlns:r="http://schemas.openxmlformats.org/officeDocument/2006/relationships" xmlns:ac="http://schemas.microsoft.com/office/drawing/2013/main/command" xmlns:pc="http://schemas.microsoft.com/office/powerpoint/2013/main/command">
   <pc:docChgLst>
-    <pc:chgData name="de-Jesus-Oliveira Victor-Adriel" userId="a708fc36-3c1b-42ab-b5e9-2e1fa3c6605e" providerId="ADAL" clId="{B5D038C0-D7A8-4B27-9154-49F0265DBC18}"/>
-    <pc:docChg chg="undo custSel modSld">
-      <pc:chgData name="de-Jesus-Oliveira Victor-Adriel" userId="a708fc36-3c1b-42ab-b5e9-2e1fa3c6605e" providerId="ADAL" clId="{B5D038C0-D7A8-4B27-9154-49F0265DBC18}" dt="2023-03-29T12:42:48.717" v="49" actId="1076"/>
+    <pc:chgData name="de-Jesus-Oliveira Victor-Adriel" userId="a708fc36-3c1b-42ab-b5e9-2e1fa3c6605e" providerId="ADAL" clId="{39AA12F0-CB51-4D67-A3A6-7C3EC2C345CA}"/>
+    <pc:docChg chg="custSel modSld">
+      <pc:chgData name="de-Jesus-Oliveira Victor-Adriel" userId="a708fc36-3c1b-42ab-b5e9-2e1fa3c6605e" providerId="ADAL" clId="{39AA12F0-CB51-4D67-A3A6-7C3EC2C345CA}" dt="2026-08-05T10:04:28.790" v="68"/>
       <pc:docMkLst>
         <pc:docMk/>
       </pc:docMkLst>
-      <pc:sldChg chg="addSp modSp mod">
-        <pc:chgData name="de-Jesus-Oliveira Victor-Adriel" userId="a708fc36-3c1b-42ab-b5e9-2e1fa3c6605e" providerId="ADAL" clId="{B5D038C0-D7A8-4B27-9154-49F0265DBC18}" dt="2023-03-29T12:42:48.717" v="49" actId="1076"/>
+      <pc:sldChg chg="addSp delSp modSp mod">
+        <pc:chgData name="de-Jesus-Oliveira Victor-Adriel" userId="a708fc36-3c1b-42ab-b5e9-2e1fa3c6605e" providerId="ADAL" clId="{39AA12F0-CB51-4D67-A3A6-7C3EC2C345CA}" dt="2026-08-05T10:04:28.790" v="68"/>
         <pc:sldMkLst>
           <pc:docMk/>
           <pc:sldMk cId="714278618" sldId="256"/>
         </pc:sldMkLst>
+        <pc:spChg chg="add del mod">
+          <ac:chgData name="de-Jesus-Oliveira Victor-Adriel" userId="a708fc36-3c1b-42ab-b5e9-2e1fa3c6605e" providerId="ADAL" clId="{39AA12F0-CB51-4D67-A3A6-7C3EC2C345CA}" dt="2026-08-05T10:02:57.549" v="8" actId="478"/>
+          <ac:spMkLst>
+            <pc:docMk/>
+            <pc:sldMk cId="714278618" sldId="256"/>
+            <ac:spMk id="2" creationId="{8266D963-5866-72F4-9BEC-EDAB849AFABB}"/>
+          </ac:spMkLst>
+        </pc:spChg>
         <pc:spChg chg="add mod">
-          <ac:chgData name="de-Jesus-Oliveira Victor-Adriel" userId="a708fc36-3c1b-42ab-b5e9-2e1fa3c6605e" providerId="ADAL" clId="{B5D038C0-D7A8-4B27-9154-49F0265DBC18}" dt="2023-03-29T12:42:37.141" v="44" actId="1035"/>
+          <ac:chgData name="de-Jesus-Oliveira Victor-Adriel" userId="a708fc36-3c1b-42ab-b5e9-2e1fa3c6605e" providerId="ADAL" clId="{39AA12F0-CB51-4D67-A3A6-7C3EC2C345CA}" dt="2026-08-05T10:02:50.775" v="7" actId="1036"/>
+          <ac:spMkLst>
+            <pc:docMk/>
+            <pc:sldMk cId="714278618" sldId="256"/>
+            <ac:spMk id="3" creationId="{E3C9478E-C60C-16E2-BB03-3614E85BBBC9}"/>
+          </ac:spMkLst>
+        </pc:spChg>
+        <pc:spChg chg="add mod">
+          <ac:chgData name="de-Jesus-Oliveira Victor-Adriel" userId="a708fc36-3c1b-42ab-b5e9-2e1fa3c6605e" providerId="ADAL" clId="{39AA12F0-CB51-4D67-A3A6-7C3EC2C345CA}" dt="2026-08-05T10:02:50.775" v="7" actId="1036"/>
+          <ac:spMkLst>
+            <pc:docMk/>
+            <pc:sldMk cId="714278618" sldId="256"/>
+            <ac:spMk id="4" creationId="{399227D3-2F8B-5085-D812-F12A89D9A806}"/>
+          </ac:spMkLst>
+        </pc:spChg>
+        <pc:spChg chg="add mod">
+          <ac:chgData name="de-Jesus-Oliveira Victor-Adriel" userId="a708fc36-3c1b-42ab-b5e9-2e1fa3c6605e" providerId="ADAL" clId="{39AA12F0-CB51-4D67-A3A6-7C3EC2C345CA}" dt="2026-08-05T10:03:34.531" v="38" actId="1037"/>
+          <ac:spMkLst>
+            <pc:docMk/>
+            <pc:sldMk cId="714278618" sldId="256"/>
+            <ac:spMk id="5" creationId="{83A12840-CCA9-FD1B-6DB4-7796E8304ECA}"/>
+          </ac:spMkLst>
+        </pc:spChg>
+        <pc:spChg chg="add mod">
+          <ac:chgData name="de-Jesus-Oliveira Victor-Adriel" userId="a708fc36-3c1b-42ab-b5e9-2e1fa3c6605e" providerId="ADAL" clId="{39AA12F0-CB51-4D67-A3A6-7C3EC2C345CA}" dt="2026-08-05T10:04:01.045" v="67" actId="20577"/>
+          <ac:spMkLst>
+            <pc:docMk/>
+            <pc:sldMk cId="714278618" sldId="256"/>
+            <ac:spMk id="12" creationId="{D6CB8D88-C4E4-7CE6-3266-EF8D2558BD97}"/>
+          </ac:spMkLst>
+        </pc:spChg>
+        <pc:spChg chg="add mod">
+          <ac:chgData name="de-Jesus-Oliveira Victor-Adriel" userId="a708fc36-3c1b-42ab-b5e9-2e1fa3c6605e" providerId="ADAL" clId="{39AA12F0-CB51-4D67-A3A6-7C3EC2C345CA}" dt="2026-08-05T10:02:50.775" v="7" actId="1036"/>
+          <ac:spMkLst>
+            <pc:docMk/>
+            <pc:sldMk cId="714278618" sldId="256"/>
+            <ac:spMk id="13" creationId="{C2E98161-4624-A722-D715-E9A34946D0D9}"/>
+          </ac:spMkLst>
+        </pc:spChg>
+        <pc:spChg chg="add mod">
+          <ac:chgData name="de-Jesus-Oliveira Victor-Adriel" userId="a708fc36-3c1b-42ab-b5e9-2e1fa3c6605e" providerId="ADAL" clId="{39AA12F0-CB51-4D67-A3A6-7C3EC2C345CA}" dt="2026-08-05T10:03:44.005" v="59" actId="1038"/>
+          <ac:spMkLst>
+            <pc:docMk/>
+            <pc:sldMk cId="714278618" sldId="256"/>
+            <ac:spMk id="14" creationId="{853AB9EF-8B56-C7D7-0D31-286E5E680DAD}"/>
+          </ac:spMkLst>
+        </pc:spChg>
+        <pc:spChg chg="mod">
+          <ac:chgData name="de-Jesus-Oliveira Victor-Adriel" userId="a708fc36-3c1b-42ab-b5e9-2e1fa3c6605e" providerId="ADAL" clId="{39AA12F0-CB51-4D67-A3A6-7C3EC2C345CA}" dt="2026-08-05T10:04:28.790" v="68"/>
           <ac:spMkLst>
             <pc:docMk/>
             <pc:sldMk cId="714278618" sldId="256"/>
             <ac:spMk id="18" creationId="{3244A64E-774C-957B-E6C2-C9EE1DF9C9CD}"/>
           </ac:spMkLst>
         </pc:spChg>
-        <pc:picChg chg="add mod">
-          <ac:chgData name="de-Jesus-Oliveira Victor-Adriel" userId="a708fc36-3c1b-42ab-b5e9-2e1fa3c6605e" providerId="ADAL" clId="{B5D038C0-D7A8-4B27-9154-49F0265DBC18}" dt="2023-03-29T12:42:48.717" v="49" actId="1076"/>
-          <ac:picMkLst>
-            <pc:docMk/>
-            <pc:sldMk cId="714278618" sldId="256"/>
-            <ac:picMk id="17" creationId="{29996B0B-3817-2C67-CE09-84D1832BE06E}"/>
-          </ac:picMkLst>
-        </pc:picChg>
       </pc:sldChg>
     </pc:docChg>
   </pc:docChgLst>
@@ -275,7 +336,7 @@
           <a:p>
             <a:fld id="{F062B5D9-91B0-4121-BC66-7AEA4CDDFB5C}" type="datetimeFigureOut">
               <a:rPr lang="de-DE" smtClean="0"/>
-              <a:t>29.03.2023</a:t>
+              <a:t>05.08.2026</a:t>
             </a:fld>
             <a:endParaRPr lang="de-DE"/>
           </a:p>
@@ -445,7 +506,7 @@
           <a:p>
             <a:fld id="{F062B5D9-91B0-4121-BC66-7AEA4CDDFB5C}" type="datetimeFigureOut">
               <a:rPr lang="de-DE" smtClean="0"/>
-              <a:t>29.03.2023</a:t>
+              <a:t>05.08.2026</a:t>
             </a:fld>
             <a:endParaRPr lang="de-DE"/>
           </a:p>
@@ -625,7 +686,7 @@
           <a:p>
             <a:fld id="{F062B5D9-91B0-4121-BC66-7AEA4CDDFB5C}" type="datetimeFigureOut">
               <a:rPr lang="de-DE" smtClean="0"/>
-              <a:t>29.03.2023</a:t>
+              <a:t>05.08.2026</a:t>
             </a:fld>
             <a:endParaRPr lang="de-DE"/>
           </a:p>
@@ -795,7 +856,7 @@
           <a:p>
             <a:fld id="{F062B5D9-91B0-4121-BC66-7AEA4CDDFB5C}" type="datetimeFigureOut">
               <a:rPr lang="de-DE" smtClean="0"/>
-              <a:t>29.03.2023</a:t>
+              <a:t>05.08.2026</a:t>
             </a:fld>
             <a:endParaRPr lang="de-DE"/>
           </a:p>
@@ -1041,7 +1102,7 @@
           <a:p>
             <a:fld id="{F062B5D9-91B0-4121-BC66-7AEA4CDDFB5C}" type="datetimeFigureOut">
               <a:rPr lang="de-DE" smtClean="0"/>
-              <a:t>29.03.2023</a:t>
+              <a:t>05.08.2026</a:t>
             </a:fld>
             <a:endParaRPr lang="de-DE"/>
           </a:p>
@@ -1273,7 +1334,7 @@
           <a:p>
             <a:fld id="{F062B5D9-91B0-4121-BC66-7AEA4CDDFB5C}" type="datetimeFigureOut">
               <a:rPr lang="de-DE" smtClean="0"/>
-              <a:t>29.03.2023</a:t>
+              <a:t>05.08.2026</a:t>
             </a:fld>
             <a:endParaRPr lang="de-DE"/>
           </a:p>
@@ -1640,7 +1701,7 @@
           <a:p>
             <a:fld id="{F062B5D9-91B0-4121-BC66-7AEA4CDDFB5C}" type="datetimeFigureOut">
               <a:rPr lang="de-DE" smtClean="0"/>
-              <a:t>29.03.2023</a:t>
+              <a:t>05.08.2026</a:t>
             </a:fld>
             <a:endParaRPr lang="de-DE"/>
           </a:p>
@@ -1758,7 +1819,7 @@
           <a:p>
             <a:fld id="{F062B5D9-91B0-4121-BC66-7AEA4CDDFB5C}" type="datetimeFigureOut">
               <a:rPr lang="de-DE" smtClean="0"/>
-              <a:t>29.03.2023</a:t>
+              <a:t>05.08.2026</a:t>
             </a:fld>
             <a:endParaRPr lang="de-DE"/>
           </a:p>
@@ -1853,7 +1914,7 @@
           <a:p>
             <a:fld id="{F062B5D9-91B0-4121-BC66-7AEA4CDDFB5C}" type="datetimeFigureOut">
               <a:rPr lang="de-DE" smtClean="0"/>
-              <a:t>29.03.2023</a:t>
+              <a:t>05.08.2026</a:t>
             </a:fld>
             <a:endParaRPr lang="de-DE"/>
           </a:p>
@@ -2130,7 +2191,7 @@
           <a:p>
             <a:fld id="{F062B5D9-91B0-4121-BC66-7AEA4CDDFB5C}" type="datetimeFigureOut">
               <a:rPr lang="de-DE" smtClean="0"/>
-              <a:t>29.03.2023</a:t>
+              <a:t>05.08.2026</a:t>
             </a:fld>
             <a:endParaRPr lang="de-DE"/>
           </a:p>
@@ -2387,7 +2448,7 @@
           <a:p>
             <a:fld id="{F062B5D9-91B0-4121-BC66-7AEA4CDDFB5C}" type="datetimeFigureOut">
               <a:rPr lang="de-DE" smtClean="0"/>
-              <a:t>29.03.2023</a:t>
+              <a:t>05.08.2026</a:t>
             </a:fld>
             <a:endParaRPr lang="de-DE"/>
           </a:p>
@@ -2600,7 +2661,7 @@
           <a:p>
             <a:fld id="{F062B5D9-91B0-4121-BC66-7AEA4CDDFB5C}" type="datetimeFigureOut">
               <a:rPr lang="de-DE" smtClean="0"/>
-              <a:t>29.03.2023</a:t>
+              <a:t>05.08.2026</a:t>
             </a:fld>
             <a:endParaRPr lang="de-DE"/>
           </a:p>
@@ -3317,8 +3378,8 @@
         </p:nvSpPr>
         <p:spPr>
           <a:xfrm rot="16200000">
-            <a:off x="12524521" y="860698"/>
-            <a:ext cx="1697901" cy="307777"/>
+            <a:off x="12524521" y="853004"/>
+            <a:ext cx="1697901" cy="323165"/>
           </a:xfrm>
           <a:prstGeom prst="rect">
             <a:avLst/>
@@ -3360,12 +3421,421 @@
           <a:p>
             <a:pPr algn="r"/>
             <a:r>
-              <a:rPr lang="de-DE" sz="700" dirty="0">
+              <a:rPr lang="de-AT" sz="800" dirty="0">
                 <a:latin typeface="Segoe UI" panose="020B0502040204020203" pitchFamily="34" charset="0"/>
                 <a:cs typeface="Segoe UI" panose="020B0502040204020203" pitchFamily="34" charset="0"/>
               </a:rPr>
-              <a:t>https://fhstp.github.io/comixplain</a:t>
-            </a:r>
+              <a:t>https://www.</a:t>
+            </a:r>
+            <a:r>
+              <a:rPr lang="de-AT" sz="800" b="1" dirty="0">
+                <a:latin typeface="Segoe UI" panose="020B0502040204020203" pitchFamily="34" charset="0"/>
+                <a:cs typeface="Segoe UI" panose="020B0502040204020203" pitchFamily="34" charset="0"/>
+              </a:rPr>
+              <a:t>comixplain.cc</a:t>
+            </a:r>
+            <a:endParaRPr lang="de-DE" sz="700" dirty="0">
+              <a:latin typeface="Segoe UI" panose="020B0502040204020203" pitchFamily="34" charset="0"/>
+              <a:cs typeface="Segoe UI" panose="020B0502040204020203" pitchFamily="34" charset="0"/>
+            </a:endParaRPr>
+          </a:p>
+        </p:txBody>
+      </p:sp>
+      <p:sp>
+        <p:nvSpPr>
+          <p:cNvPr id="3" name="Rectangle 2">
+            <a:extLst>
+              <a:ext uri="{FF2B5EF4-FFF2-40B4-BE49-F238E27FC236}">
+                <a16:creationId xmlns:a16="http://schemas.microsoft.com/office/drawing/2014/main" id="{E3C9478E-C60C-16E2-BB03-3614E85BBBC9}"/>
+              </a:ext>
+              <a:ext uri="{C183D7F6-B498-43B3-948B-1728B52AA6E4}">
+                <adec:decorative xmlns:adec="http://schemas.microsoft.com/office/drawing/2017/decorative" val="1"/>
+              </a:ext>
+            </a:extLst>
+          </p:cNvPr>
+          <p:cNvSpPr/>
+          <p:nvPr/>
+        </p:nvSpPr>
+        <p:spPr>
+          <a:xfrm>
+            <a:off x="8813198" y="1844862"/>
+            <a:ext cx="1304925" cy="298450"/>
+          </a:xfrm>
+          <a:prstGeom prst="rect">
+            <a:avLst/>
+          </a:prstGeom>
+          <a:solidFill>
+            <a:srgbClr val="FFFFFF"/>
+          </a:solidFill>
+          <a:ln>
+            <a:solidFill>
+              <a:schemeClr val="bg1"/>
+            </a:solidFill>
+          </a:ln>
+        </p:spPr>
+        <p:style>
+          <a:lnRef idx="2">
+            <a:schemeClr val="accent1">
+              <a:shade val="15000"/>
+            </a:schemeClr>
+          </a:lnRef>
+          <a:fillRef idx="1">
+            <a:schemeClr val="accent1"/>
+          </a:fillRef>
+          <a:effectRef idx="0">
+            <a:schemeClr val="accent1"/>
+          </a:effectRef>
+          <a:fontRef idx="minor">
+            <a:schemeClr val="lt1"/>
+          </a:fontRef>
+        </p:style>
+        <p:txBody>
+          <a:bodyPr rtlCol="0" anchor="ctr"/>
+          <a:lstStyle/>
+          <a:p>
+            <a:pPr algn="ctr"/>
+            <a:endParaRPr lang="en-US"/>
+          </a:p>
+        </p:txBody>
+      </p:sp>
+      <p:sp>
+        <p:nvSpPr>
+          <p:cNvPr id="4" name="Rectangle 3">
+            <a:extLst>
+              <a:ext uri="{FF2B5EF4-FFF2-40B4-BE49-F238E27FC236}">
+                <a16:creationId xmlns:a16="http://schemas.microsoft.com/office/drawing/2014/main" id="{399227D3-2F8B-5085-D812-F12A89D9A806}"/>
+              </a:ext>
+              <a:ext uri="{C183D7F6-B498-43B3-948B-1728B52AA6E4}">
+                <adec:decorative xmlns:adec="http://schemas.microsoft.com/office/drawing/2017/decorative" val="1"/>
+              </a:ext>
+            </a:extLst>
+          </p:cNvPr>
+          <p:cNvSpPr/>
+          <p:nvPr/>
+        </p:nvSpPr>
+        <p:spPr>
+          <a:xfrm>
+            <a:off x="9822848" y="2672124"/>
+            <a:ext cx="1177925" cy="298450"/>
+          </a:xfrm>
+          <a:prstGeom prst="rect">
+            <a:avLst/>
+          </a:prstGeom>
+          <a:solidFill>
+            <a:srgbClr val="FFFFFF"/>
+          </a:solidFill>
+          <a:ln>
+            <a:solidFill>
+              <a:schemeClr val="bg1"/>
+            </a:solidFill>
+          </a:ln>
+        </p:spPr>
+        <p:style>
+          <a:lnRef idx="2">
+            <a:schemeClr val="accent1">
+              <a:shade val="15000"/>
+            </a:schemeClr>
+          </a:lnRef>
+          <a:fillRef idx="1">
+            <a:schemeClr val="accent1"/>
+          </a:fillRef>
+          <a:effectRef idx="0">
+            <a:schemeClr val="accent1"/>
+          </a:effectRef>
+          <a:fontRef idx="minor">
+            <a:schemeClr val="lt1"/>
+          </a:fontRef>
+        </p:style>
+        <p:txBody>
+          <a:bodyPr rtlCol="0" anchor="ctr"/>
+          <a:lstStyle/>
+          <a:p>
+            <a:pPr algn="ctr"/>
+            <a:endParaRPr lang="en-US"/>
+          </a:p>
+        </p:txBody>
+      </p:sp>
+      <p:sp>
+        <p:nvSpPr>
+          <p:cNvPr id="5" name="Rectangle 4">
+            <a:extLst>
+              <a:ext uri="{FF2B5EF4-FFF2-40B4-BE49-F238E27FC236}">
+                <a16:creationId xmlns:a16="http://schemas.microsoft.com/office/drawing/2014/main" id="{83A12840-CCA9-FD1B-6DB4-7796E8304ECA}"/>
+              </a:ext>
+              <a:ext uri="{C183D7F6-B498-43B3-948B-1728B52AA6E4}">
+                <adec:decorative xmlns:adec="http://schemas.microsoft.com/office/drawing/2017/decorative" val="1"/>
+              </a:ext>
+            </a:extLst>
+          </p:cNvPr>
+          <p:cNvSpPr/>
+          <p:nvPr/>
+        </p:nvSpPr>
+        <p:spPr>
+          <a:xfrm>
+            <a:off x="11525928" y="2686583"/>
+            <a:ext cx="1238250" cy="298450"/>
+          </a:xfrm>
+          <a:prstGeom prst="rect">
+            <a:avLst/>
+          </a:prstGeom>
+          <a:solidFill>
+            <a:srgbClr val="FFFFFF"/>
+          </a:solidFill>
+          <a:ln>
+            <a:solidFill>
+              <a:schemeClr val="bg1"/>
+            </a:solidFill>
+          </a:ln>
+        </p:spPr>
+        <p:style>
+          <a:lnRef idx="2">
+            <a:schemeClr val="accent1">
+              <a:shade val="15000"/>
+            </a:schemeClr>
+          </a:lnRef>
+          <a:fillRef idx="1">
+            <a:schemeClr val="accent1"/>
+          </a:fillRef>
+          <a:effectRef idx="0">
+            <a:schemeClr val="accent1"/>
+          </a:effectRef>
+          <a:fontRef idx="minor">
+            <a:schemeClr val="lt1"/>
+          </a:fontRef>
+        </p:style>
+        <p:txBody>
+          <a:bodyPr rtlCol="0" anchor="ctr"/>
+          <a:lstStyle/>
+          <a:p>
+            <a:pPr algn="ctr"/>
+            <a:endParaRPr lang="en-US"/>
+          </a:p>
+        </p:txBody>
+      </p:sp>
+      <p:sp>
+        <p:nvSpPr>
+          <p:cNvPr id="12" name="TextBox 11">
+            <a:extLst>
+              <a:ext uri="{FF2B5EF4-FFF2-40B4-BE49-F238E27FC236}">
+                <a16:creationId xmlns:a16="http://schemas.microsoft.com/office/drawing/2014/main" id="{D6CB8D88-C4E4-7CE6-3266-EF8D2558BD97}"/>
+              </a:ext>
+            </a:extLst>
+          </p:cNvPr>
+          <p:cNvSpPr txBox="1"/>
+          <p:nvPr/>
+        </p:nvSpPr>
+        <p:spPr>
+          <a:xfrm>
+            <a:off x="8754324" y="1804388"/>
+            <a:ext cx="1459048" cy="369332"/>
+          </a:xfrm>
+          <a:prstGeom prst="rect">
+            <a:avLst/>
+          </a:prstGeom>
+          <a:noFill/>
+        </p:spPr>
+        <p:txBody>
+          <a:bodyPr wrap="square" rtlCol="0">
+            <a:spAutoFit/>
+          </a:bodyPr>
+          <a:lstStyle/>
+          <a:p>
+            <a:r>
+              <a:rPr lang="es-419" sz="900" dirty="0" err="1">
+                <a:latin typeface="Pangolin" panose="00000500000000000000" pitchFamily="2" charset="0"/>
+              </a:rPr>
+              <a:t>e.g</a:t>
+            </a:r>
+            <a:r>
+              <a:rPr lang="es-419" sz="900" dirty="0">
+                <a:latin typeface="Pangolin" panose="00000500000000000000" pitchFamily="2" charset="0"/>
+              </a:rPr>
+              <a:t>., color, </a:t>
+            </a:r>
+            <a:r>
+              <a:rPr lang="es-419" sz="900" dirty="0" err="1">
+                <a:latin typeface="Pangolin" panose="00000500000000000000" pitchFamily="2" charset="0"/>
+              </a:rPr>
+              <a:t>genre</a:t>
+            </a:r>
+            <a:r>
+              <a:rPr lang="es-419" sz="900" dirty="0">
+                <a:latin typeface="Pangolin" panose="00000500000000000000" pitchFamily="2" charset="0"/>
+              </a:rPr>
+              <a:t>, </a:t>
+            </a:r>
+            <a:r>
+              <a:rPr lang="es-419" sz="900" dirty="0" err="1">
+                <a:latin typeface="Pangolin" panose="00000500000000000000" pitchFamily="2" charset="0"/>
+              </a:rPr>
+              <a:t>author</a:t>
+            </a:r>
+            <a:r>
+              <a:rPr lang="es-419" sz="900" dirty="0">
+                <a:latin typeface="Pangolin" panose="00000500000000000000" pitchFamily="2" charset="0"/>
+              </a:rPr>
+              <a:t>,</a:t>
+            </a:r>
+            <a:br>
+              <a:rPr lang="es-419" sz="900" dirty="0">
+                <a:latin typeface="Pangolin" panose="00000500000000000000" pitchFamily="2" charset="0"/>
+              </a:rPr>
+            </a:br>
+            <a:r>
+              <a:rPr lang="es-419" sz="900" dirty="0" err="1">
+                <a:latin typeface="Pangolin" panose="00000500000000000000" pitchFamily="2" charset="0"/>
+              </a:rPr>
+              <a:t>language</a:t>
+            </a:r>
+            <a:r>
+              <a:rPr lang="es-419" sz="900" dirty="0">
+                <a:latin typeface="Pangolin" panose="00000500000000000000" pitchFamily="2" charset="0"/>
+              </a:rPr>
+              <a:t>…</a:t>
+            </a:r>
+            <a:endParaRPr lang="pt-BR" sz="900" dirty="0"/>
+          </a:p>
+        </p:txBody>
+      </p:sp>
+      <p:sp>
+        <p:nvSpPr>
+          <p:cNvPr id="13" name="TextBox 12">
+            <a:extLst>
+              <a:ext uri="{FF2B5EF4-FFF2-40B4-BE49-F238E27FC236}">
+                <a16:creationId xmlns:a16="http://schemas.microsoft.com/office/drawing/2014/main" id="{C2E98161-4624-A722-D715-E9A34946D0D9}"/>
+              </a:ext>
+            </a:extLst>
+          </p:cNvPr>
+          <p:cNvSpPr txBox="1"/>
+          <p:nvPr/>
+        </p:nvSpPr>
+        <p:spPr>
+          <a:xfrm>
+            <a:off x="9763093" y="2639542"/>
+            <a:ext cx="1350423" cy="369332"/>
+          </a:xfrm>
+          <a:prstGeom prst="rect">
+            <a:avLst/>
+          </a:prstGeom>
+          <a:noFill/>
+        </p:spPr>
+        <p:txBody>
+          <a:bodyPr wrap="square" rtlCol="0">
+            <a:spAutoFit/>
+          </a:bodyPr>
+          <a:lstStyle/>
+          <a:p>
+            <a:r>
+              <a:rPr lang="es-419" sz="900" dirty="0" err="1">
+                <a:latin typeface="Pangolin" panose="00000500000000000000" pitchFamily="2" charset="0"/>
+              </a:rPr>
+              <a:t>educational</a:t>
+            </a:r>
+            <a:r>
+              <a:rPr lang="es-419" sz="900" dirty="0">
+                <a:latin typeface="Pangolin" panose="00000500000000000000" pitchFamily="2" charset="0"/>
+              </a:rPr>
+              <a:t> </a:t>
+            </a:r>
+            <a:r>
+              <a:rPr lang="es-419" sz="900" dirty="0" err="1">
+                <a:latin typeface="Pangolin" panose="00000500000000000000" pitchFamily="2" charset="0"/>
+              </a:rPr>
+              <a:t>level</a:t>
+            </a:r>
+            <a:r>
+              <a:rPr lang="es-419" sz="900" dirty="0">
+                <a:latin typeface="Pangolin" panose="00000500000000000000" pitchFamily="2" charset="0"/>
+              </a:rPr>
+              <a:t>, t-</a:t>
+            </a:r>
+            <a:r>
+              <a:rPr lang="es-419" sz="900" dirty="0" err="1">
+                <a:latin typeface="Pangolin" panose="00000500000000000000" pitchFamily="2" charset="0"/>
+              </a:rPr>
+              <a:t>shirt</a:t>
+            </a:r>
+            <a:r>
+              <a:rPr lang="es-419" sz="900" dirty="0">
+                <a:latin typeface="Pangolin" panose="00000500000000000000" pitchFamily="2" charset="0"/>
+              </a:rPr>
+              <a:t> </a:t>
+            </a:r>
+            <a:r>
+              <a:rPr lang="es-419" sz="900" dirty="0" err="1">
+                <a:latin typeface="Pangolin" panose="00000500000000000000" pitchFamily="2" charset="0"/>
+              </a:rPr>
+              <a:t>size</a:t>
+            </a:r>
+            <a:r>
+              <a:rPr lang="es-419" sz="900" dirty="0">
+                <a:latin typeface="Pangolin" panose="00000500000000000000" pitchFamily="2" charset="0"/>
+              </a:rPr>
+              <a:t>, </a:t>
+            </a:r>
+            <a:r>
+              <a:rPr lang="es-419" sz="900" dirty="0" err="1">
+                <a:latin typeface="Pangolin" panose="00000500000000000000" pitchFamily="2" charset="0"/>
+              </a:rPr>
+              <a:t>age</a:t>
+            </a:r>
+            <a:r>
+              <a:rPr lang="es-419" sz="900" dirty="0">
+                <a:latin typeface="Pangolin" panose="00000500000000000000" pitchFamily="2" charset="0"/>
+              </a:rPr>
+              <a:t> </a:t>
+            </a:r>
+            <a:r>
+              <a:rPr lang="es-419" sz="900" dirty="0" err="1">
+                <a:latin typeface="Pangolin" panose="00000500000000000000" pitchFamily="2" charset="0"/>
+              </a:rPr>
+              <a:t>group</a:t>
+            </a:r>
+            <a:r>
+              <a:rPr lang="es-419" sz="900" dirty="0">
+                <a:latin typeface="Pangolin" panose="00000500000000000000" pitchFamily="2" charset="0"/>
+              </a:rPr>
+              <a:t>…</a:t>
+            </a:r>
+            <a:endParaRPr lang="pt-BR" sz="900" dirty="0"/>
+          </a:p>
+        </p:txBody>
+      </p:sp>
+      <p:sp>
+        <p:nvSpPr>
+          <p:cNvPr id="14" name="TextBox 13">
+            <a:extLst>
+              <a:ext uri="{FF2B5EF4-FFF2-40B4-BE49-F238E27FC236}">
+                <a16:creationId xmlns:a16="http://schemas.microsoft.com/office/drawing/2014/main" id="{853AB9EF-8B56-C7D7-0D31-286E5E680DAD}"/>
+              </a:ext>
+            </a:extLst>
+          </p:cNvPr>
+          <p:cNvSpPr txBox="1"/>
+          <p:nvPr/>
+        </p:nvSpPr>
+        <p:spPr>
+          <a:xfrm>
+            <a:off x="11455963" y="2646042"/>
+            <a:ext cx="1459048" cy="369332"/>
+          </a:xfrm>
+          <a:prstGeom prst="rect">
+            <a:avLst/>
+          </a:prstGeom>
+          <a:noFill/>
+        </p:spPr>
+        <p:txBody>
+          <a:bodyPr wrap="square" rtlCol="0">
+            <a:spAutoFit/>
+          </a:bodyPr>
+          <a:lstStyle/>
+          <a:p>
+            <a:r>
+              <a:rPr lang="pt-BR" sz="900" dirty="0">
+                <a:latin typeface="Pangolin" panose="00000500000000000000" pitchFamily="2" charset="0"/>
+              </a:rPr>
+              <a:t>centimeters, kilograms, exact age, temperature...</a:t>
+            </a:r>
+            <a:endParaRPr lang="pt-BR" sz="900" dirty="0"/>
           </a:p>
         </p:txBody>
       </p:sp>
@@ -3644,6 +4114,26 @@
 </file>
 
 <file path=customXml/item1.xml><?xml version="1.0" encoding="utf-8"?>
+<p:properties xmlns:p="http://schemas.microsoft.com/office/2006/metadata/properties" xmlns:xsi="http://www.w3.org/2001/XMLSchema-instance" xmlns:pc="http://schemas.microsoft.com/office/infopath/2007/PartnerControls">
+  <documentManagement>
+    <lcf76f155ced4ddcb4097134ff3c332f xmlns="da1b7603-f8b8-47c9-9682-dc6aa8e9acd7">
+      <Terms xmlns="http://schemas.microsoft.com/office/infopath/2007/PartnerControls"/>
+    </lcf76f155ced4ddcb4097134ff3c332f>
+    <TaxCatchAll xmlns="94bcf745-830c-42f4-885c-a1d7342e6e36" xsi:nil="true"/>
+  </documentManagement>
+</p:properties>
+</file>
+
+<file path=customXml/item2.xml><?xml version="1.0" encoding="utf-8"?>
+<?mso-contentType ?>
+<FormTemplates xmlns="http://schemas.microsoft.com/sharepoint/v3/contenttype/forms">
+  <Display>DocumentLibraryForm</Display>
+  <Edit>DocumentLibraryForm</Edit>
+  <New>DocumentLibraryForm</New>
+</FormTemplates>
+</file>
+
+<file path=customXml/item3.xml><?xml version="1.0" encoding="utf-8"?>
 <ct:contentTypeSchema xmlns:ct="http://schemas.microsoft.com/office/2006/metadata/contentType" xmlns:ma="http://schemas.microsoft.com/office/2006/metadata/properties/metaAttributes" ct:_="" ma:_="" ma:contentTypeName="Dokument" ma:contentTypeID="0x0101009BF7B09DBF6D7B4DA35692C22AFAF86F" ma:contentTypeVersion="16" ma:contentTypeDescription="Ein neues Dokument erstellen." ma:contentTypeScope="" ma:versionID="a5f25a2d2f3966261c4134713dfa4526">
   <xsd:schema xmlns:xsd="http://www.w3.org/2001/XMLSchema" xmlns:xs="http://www.w3.org/2001/XMLSchema" xmlns:p="http://schemas.microsoft.com/office/2006/metadata/properties" xmlns:ns2="da1b7603-f8b8-47c9-9682-dc6aa8e9acd7" xmlns:ns3="94bcf745-830c-42f4-885c-a1d7342e6e36" targetNamespace="http://schemas.microsoft.com/office/2006/metadata/properties" ma:root="true" ma:fieldsID="3bd5b08873ef7f837dc9b940f7d80505" ns2:_="" ns3:_="">
     <xsd:import namespace="da1b7603-f8b8-47c9-9682-dc6aa8e9acd7"/>
@@ -3886,34 +4376,40 @@
 </ct:contentTypeSchema>
 </file>
 
-<file path=customXml/item2.xml><?xml version="1.0" encoding="utf-8"?>
-<?mso-contentType ?>
-<FormTemplates xmlns="http://schemas.microsoft.com/sharepoint/v3/contenttype/forms">
-  <Display>DocumentLibraryForm</Display>
-  <Edit>DocumentLibraryForm</Edit>
-  <New>DocumentLibraryForm</New>
-</FormTemplates>
-</file>
-
-<file path=customXml/item3.xml><?xml version="1.0" encoding="utf-8"?>
-<p:properties xmlns:p="http://schemas.microsoft.com/office/2006/metadata/properties" xmlns:xsi="http://www.w3.org/2001/XMLSchema-instance" xmlns:pc="http://schemas.microsoft.com/office/infopath/2007/PartnerControls">
-  <documentManagement>
-    <lcf76f155ced4ddcb4097134ff3c332f xmlns="da1b7603-f8b8-47c9-9682-dc6aa8e9acd7">
-      <Terms xmlns="http://schemas.microsoft.com/office/infopath/2007/PartnerControls"/>
-    </lcf76f155ced4ddcb4097134ff3c332f>
-    <TaxCatchAll xmlns="94bcf745-830c-42f4-885c-a1d7342e6e36" xsi:nil="true"/>
-  </documentManagement>
-</p:properties>
-</file>
-
 <file path=customXml/itemProps1.xml><?xml version="1.0" encoding="utf-8"?>
-<ds:datastoreItem xmlns:ds="http://schemas.openxmlformats.org/officeDocument/2006/customXml" ds:itemID="{B0826EA0-4482-4986-B06B-ABF2C74664C5}"/>
+<ds:datastoreItem xmlns:ds="http://schemas.openxmlformats.org/officeDocument/2006/customXml" ds:itemID="{2807E709-41E9-47FE-B641-EBFB148137C6}">
+  <ds:schemaRefs>
+    <ds:schemaRef ds:uri="http://schemas.microsoft.com/office/2006/metadata/properties"/>
+    <ds:schemaRef ds:uri="http://schemas.microsoft.com/office/infopath/2007/PartnerControls"/>
+    <ds:schemaRef ds:uri="da1b7603-f8b8-47c9-9682-dc6aa8e9acd7"/>
+    <ds:schemaRef ds:uri="94bcf745-830c-42f4-885c-a1d7342e6e36"/>
+  </ds:schemaRefs>
+</ds:datastoreItem>
 </file>
 
 <file path=customXml/itemProps2.xml><?xml version="1.0" encoding="utf-8"?>
-<ds:datastoreItem xmlns:ds="http://schemas.openxmlformats.org/officeDocument/2006/customXml" ds:itemID="{F259FF6D-7A7C-4109-96FE-3BA9DA5158AB}"/>
+<ds:datastoreItem xmlns:ds="http://schemas.openxmlformats.org/officeDocument/2006/customXml" ds:itemID="{F259FF6D-7A7C-4109-96FE-3BA9DA5158AB}">
+  <ds:schemaRefs>
+    <ds:schemaRef ds:uri="http://schemas.microsoft.com/sharepoint/v3/contenttype/forms"/>
+  </ds:schemaRefs>
+</ds:datastoreItem>
 </file>
 
 <file path=customXml/itemProps3.xml><?xml version="1.0" encoding="utf-8"?>
-<ds:datastoreItem xmlns:ds="http://schemas.openxmlformats.org/officeDocument/2006/customXml" ds:itemID="{2807E709-41E9-47FE-B641-EBFB148137C6}"/>
+<ds:datastoreItem xmlns:ds="http://schemas.openxmlformats.org/officeDocument/2006/customXml" ds:itemID="{B0826EA0-4482-4986-B06B-ABF2C74664C5}">
+  <ds:schemaRefs>
+    <ds:schemaRef ds:uri="http://schemas.microsoft.com/office/2006/metadata/contentType"/>
+    <ds:schemaRef ds:uri="http://schemas.microsoft.com/office/2006/metadata/properties/metaAttributes"/>
+    <ds:schemaRef ds:uri="http://www.w3.org/2001/XMLSchema"/>
+    <ds:schemaRef ds:uri="http://schemas.microsoft.com/office/2006/metadata/properties"/>
+    <ds:schemaRef ds:uri="da1b7603-f8b8-47c9-9682-dc6aa8e9acd7"/>
+    <ds:schemaRef ds:uri="94bcf745-830c-42f4-885c-a1d7342e6e36"/>
+    <ds:schemaRef ds:uri="http://schemas.microsoft.com/office/2006/documentManagement/types"/>
+    <ds:schemaRef ds:uri="http://schemas.microsoft.com/office/infopath/2007/PartnerControls"/>
+    <ds:schemaRef ds:uri="http://schemas.openxmlformats.org/package/2006/metadata/core-properties"/>
+    <ds:schemaRef ds:uri="http://purl.org/dc/elements/1.1/"/>
+    <ds:schemaRef ds:uri="http://purl.org/dc/terms/"/>
+    <ds:schemaRef ds:uri="http://schemas.microsoft.com/internal/obd"/>
+  </ds:schemaRefs>
+</ds:datastoreItem>
 </file>
</xml_diff>